<commit_message>
Remove leftover empty text box from slide 13
Co-Authored-By: Claude Opus 5.5 <noreply@anthropic.com>
Claude-Session: https://claude.ai/code/session_019F1EE7Mh2qzNY55TmpiNny
</commit_message>
<xml_diff>
--- a/docs/presentation/2026-09-28-mentoring/NOVA_발표_v16.pptx
+++ b/docs/presentation/2026-09-28-mentoring/NOVA_발표_v16.pptx
@@ -32929,51 +32929,6 @@
           </a:p>
         </p:txBody>
       </p:sp>
-      <p:sp>
-        <p:nvSpPr>
-          <p:cNvPr id="54" name="TextBox 53"/>
-          <p:cNvSpPr txBox="1"/>
-          <p:nvPr/>
-        </p:nvSpPr>
-        <p:spPr>
-          <a:xfrm>
-            <a:off x="4718304" y="6254496"/>
-            <a:ext cx="3822192" cy="9144"/>
-          </a:xfrm>
-          <a:prstGeom prst="rect">
-            <a:avLst/>
-          </a:prstGeom>
-          <a:noFill/>
-        </p:spPr>
-        <p:txBody>
-          <a:bodyPr wrap="square" lIns="36576" tIns="18288" rIns="36576" bIns="18288" anchor="t">
-            <a:noAutofit/>
-          </a:bodyPr>
-          <a:lstStyle/>
-          <a:p>
-            <a:pPr algn="l">
-              <a:spcBef>
-                <a:spcPts val="0"/>
-              </a:spcBef>
-              <a:spcAft>
-                <a:spcPts val="0"/>
-              </a:spcAft>
-              <a:buNone/>
-            </a:pPr>
-            <a:r>
-              <a:rPr sz="200" b="0" lang="ko-KR">
-                <a:solidFill>
-                  <a:srgbClr val="3C4043"/>
-                </a:solidFill>
-                <a:latin typeface="Calibri"/>
-                <a:ea typeface="Noto Sans KR"/>
-                <a:cs typeface="Calibri"/>
-              </a:rPr>
-              <a:t/>
-            </a:r>
-          </a:p>
-        </p:txBody>
-      </p:sp>
     </p:spTree>
   </p:cSld>
   <p:clrMapOvr>

</xml_diff>